<commit_message>
Presentation fixed bt + last slide
</commit_message>
<xml_diff>
--- a/GPP_ZombieAI_CarvalhoAna_2DAE11.pptx
+++ b/GPP_ZombieAI_CarvalhoAna_2DAE11.pptx
@@ -341,7 +341,7 @@
           <a:p>
             <a:fld id="{4F28A817-5CD2-44D0-A5CF-3D5A348D72FB}" type="datetimeFigureOut">
               <a:rPr lang="pt-PT" smtClean="0"/>
-              <a:t>02/06/2026</a:t>
+              <a:t>05/06/2026</a:t>
             </a:fld>
             <a:endParaRPr lang="pt-PT"/>
           </a:p>
@@ -1168,7 +1168,7 @@
           <a:p>
             <a:fld id="{82085877-2B37-48E7-8B6D-4D4ED486130A}" type="datetimeFigureOut">
               <a:rPr lang="en-BE" smtClean="0"/>
-              <a:t>06/02/2026</a:t>
+              <a:t>06/05/2026</a:t>
             </a:fld>
             <a:endParaRPr lang="en-BE"/>
           </a:p>
@@ -1338,7 +1338,7 @@
           <a:p>
             <a:fld id="{82085877-2B37-48E7-8B6D-4D4ED486130A}" type="datetimeFigureOut">
               <a:rPr lang="en-BE" smtClean="0"/>
-              <a:t>06/02/2026</a:t>
+              <a:t>06/05/2026</a:t>
             </a:fld>
             <a:endParaRPr lang="en-BE"/>
           </a:p>
@@ -1518,7 +1518,7 @@
           <a:p>
             <a:fld id="{82085877-2B37-48E7-8B6D-4D4ED486130A}" type="datetimeFigureOut">
               <a:rPr lang="en-BE" smtClean="0"/>
-              <a:t>06/02/2026</a:t>
+              <a:t>06/05/2026</a:t>
             </a:fld>
             <a:endParaRPr lang="en-BE"/>
           </a:p>
@@ -1688,7 +1688,7 @@
           <a:p>
             <a:fld id="{82085877-2B37-48E7-8B6D-4D4ED486130A}" type="datetimeFigureOut">
               <a:rPr lang="en-BE" smtClean="0"/>
-              <a:t>06/02/2026</a:t>
+              <a:t>06/05/2026</a:t>
             </a:fld>
             <a:endParaRPr lang="en-BE"/>
           </a:p>
@@ -1934,7 +1934,7 @@
           <a:p>
             <a:fld id="{82085877-2B37-48E7-8B6D-4D4ED486130A}" type="datetimeFigureOut">
               <a:rPr lang="en-BE" smtClean="0"/>
-              <a:t>06/02/2026</a:t>
+              <a:t>06/05/2026</a:t>
             </a:fld>
             <a:endParaRPr lang="en-BE"/>
           </a:p>
@@ -2166,7 +2166,7 @@
           <a:p>
             <a:fld id="{82085877-2B37-48E7-8B6D-4D4ED486130A}" type="datetimeFigureOut">
               <a:rPr lang="en-BE" smtClean="0"/>
-              <a:t>06/02/2026</a:t>
+              <a:t>06/05/2026</a:t>
             </a:fld>
             <a:endParaRPr lang="en-BE"/>
           </a:p>
@@ -2533,7 +2533,7 @@
           <a:p>
             <a:fld id="{82085877-2B37-48E7-8B6D-4D4ED486130A}" type="datetimeFigureOut">
               <a:rPr lang="en-BE" smtClean="0"/>
-              <a:t>06/02/2026</a:t>
+              <a:t>06/05/2026</a:t>
             </a:fld>
             <a:endParaRPr lang="en-BE"/>
           </a:p>
@@ -2651,7 +2651,7 @@
           <a:p>
             <a:fld id="{82085877-2B37-48E7-8B6D-4D4ED486130A}" type="datetimeFigureOut">
               <a:rPr lang="en-BE" smtClean="0"/>
-              <a:t>06/02/2026</a:t>
+              <a:t>06/05/2026</a:t>
             </a:fld>
             <a:endParaRPr lang="en-BE"/>
           </a:p>
@@ -2746,7 +2746,7 @@
           <a:p>
             <a:fld id="{82085877-2B37-48E7-8B6D-4D4ED486130A}" type="datetimeFigureOut">
               <a:rPr lang="en-BE" smtClean="0"/>
-              <a:t>06/02/2026</a:t>
+              <a:t>06/05/2026</a:t>
             </a:fld>
             <a:endParaRPr lang="en-BE"/>
           </a:p>
@@ -3023,7 +3023,7 @@
           <a:p>
             <a:fld id="{82085877-2B37-48E7-8B6D-4D4ED486130A}" type="datetimeFigureOut">
               <a:rPr lang="en-BE" smtClean="0"/>
-              <a:t>06/02/2026</a:t>
+              <a:t>06/05/2026</a:t>
             </a:fld>
             <a:endParaRPr lang="en-BE"/>
           </a:p>
@@ -3280,7 +3280,7 @@
           <a:p>
             <a:fld id="{82085877-2B37-48E7-8B6D-4D4ED486130A}" type="datetimeFigureOut">
               <a:rPr lang="en-BE" smtClean="0"/>
-              <a:t>06/02/2026</a:t>
+              <a:t>06/05/2026</a:t>
             </a:fld>
             <a:endParaRPr lang="en-BE"/>
           </a:p>
@@ -3493,7 +3493,7 @@
           <a:p>
             <a:fld id="{82085877-2B37-48E7-8B6D-4D4ED486130A}" type="datetimeFigureOut">
               <a:rPr lang="en-BE" smtClean="0"/>
-              <a:t>06/02/2026</a:t>
+              <a:t>06/05/2026</a:t>
             </a:fld>
             <a:endParaRPr lang="en-BE"/>
           </a:p>
@@ -4137,10 +4137,10 @@
       </p:sp>
       <p:pic>
         <p:nvPicPr>
-          <p:cNvPr id="12" name="Imagem 11">
+          <p:cNvPr id="3" name="Imagem 2">
             <a:extLst>
               <a:ext uri="{FF2B5EF4-FFF2-40B4-BE49-F238E27FC236}">
-                <a16:creationId xmlns:a16="http://schemas.microsoft.com/office/drawing/2014/main" id="{2F786E44-827E-E65C-118C-6F3C671EB562}"/>
+                <a16:creationId xmlns:a16="http://schemas.microsoft.com/office/drawing/2014/main" id="{49C16277-A08A-4EEB-8129-602886EE00B7}"/>
               </a:ext>
             </a:extLst>
           </p:cNvPr>
@@ -4489,79 +4489,42 @@
           <a:chExt cx="0" cy="0"/>
         </a:xfrm>
       </p:grpSpPr>
-      <p:sp>
-        <p:nvSpPr>
-          <p:cNvPr id="2" name="Title 1">
+      <p:pic>
+        <p:nvPicPr>
+          <p:cNvPr id="9" name="Imagem 8">
             <a:extLst>
               <a:ext uri="{FF2B5EF4-FFF2-40B4-BE49-F238E27FC236}">
-                <a16:creationId xmlns:a16="http://schemas.microsoft.com/office/drawing/2014/main" id="{EF6BB071-C63E-40D3-93C6-9F99F27862FE}"/>
+                <a16:creationId xmlns:a16="http://schemas.microsoft.com/office/drawing/2014/main" id="{B834D7D7-A0AE-D809-9343-81926AC9C610}"/>
               </a:ext>
             </a:extLst>
           </p:cNvPr>
-          <p:cNvSpPr>
-            <a:spLocks noGrp="1"/>
-          </p:cNvSpPr>
-          <p:nvPr>
-            <p:ph type="title"/>
-          </p:nvPr>
-        </p:nvSpPr>
-        <p:spPr/>
-        <p:txBody>
-          <a:bodyPr/>
-          <a:lstStyle/>
-          <a:p>
-            <a:r>
-              <a:rPr lang="en-US"/>
-              <a:t>High Score</a:t>
-            </a:r>
-            <a:endParaRPr lang="en-BE"/>
-          </a:p>
-        </p:txBody>
-      </p:sp>
-      <p:sp>
-        <p:nvSpPr>
-          <p:cNvPr id="3" name="Content Placeholder 2">
+          <p:cNvPicPr>
+            <a:picLocks noChangeAspect="1"/>
+          </p:cNvPicPr>
+          <p:nvPr/>
+        </p:nvPicPr>
+        <p:blipFill>
+          <a:blip r:embed="rId2">
             <a:extLst>
-              <a:ext uri="{FF2B5EF4-FFF2-40B4-BE49-F238E27FC236}">
-                <a16:creationId xmlns:a16="http://schemas.microsoft.com/office/drawing/2014/main" id="{64915428-ACD8-4B22-96DC-2806680ED3AB}"/>
+              <a:ext uri="{28A0092B-C50C-407E-A947-70E740481C1C}">
+                <a14:useLocalDpi xmlns:a14="http://schemas.microsoft.com/office/drawing/2010/main" val="0"/>
               </a:ext>
             </a:extLst>
-          </p:cNvPr>
-          <p:cNvSpPr>
-            <a:spLocks noGrp="1"/>
-          </p:cNvSpPr>
-          <p:nvPr>
-            <p:ph idx="1"/>
-          </p:nvPr>
-        </p:nvSpPr>
-        <p:spPr/>
-        <p:txBody>
-          <a:bodyPr/>
-          <a:lstStyle/>
-          <a:p>
-            <a:pPr marL="0" indent="0">
-              <a:buNone/>
-            </a:pPr>
-            <a:r>
-              <a:rPr lang="en-US" dirty="0">
-                <a:solidFill>
-                  <a:schemeClr val="bg1">
-                    <a:lumMod val="75000"/>
-                  </a:schemeClr>
-                </a:solidFill>
-              </a:rPr>
-              <a:t>Ignore this title add whatever I want here!</a:t>
-            </a:r>
-            <a:endParaRPr lang="en-BE" dirty="0">
-              <a:solidFill>
-                <a:schemeClr val="bg1">
-                  <a:lumMod val="75000"/>
-                </a:schemeClr>
-              </a:solidFill>
-            </a:endParaRPr>
-          </a:p>
-        </p:txBody>
-      </p:sp>
+          </a:blip>
+          <a:stretch>
+            <a:fillRect/>
+          </a:stretch>
+        </p:blipFill>
+        <p:spPr>
+          <a:xfrm>
+            <a:off x="0" y="0"/>
+            <a:ext cx="12192000" cy="6858000"/>
+          </a:xfrm>
+          <a:prstGeom prst="rect">
+            <a:avLst/>
+          </a:prstGeom>
+        </p:spPr>
+      </p:pic>
     </p:spTree>
     <p:extLst>
       <p:ext uri="{BB962C8B-B14F-4D97-AF65-F5344CB8AC3E}">
@@ -5152,15 +5115,6 @@
 </file>
 
 <file path=customXml/item1.xml><?xml version="1.0" encoding="utf-8"?>
-<?mso-contentType ?>
-<FormTemplates xmlns="http://schemas.microsoft.com/sharepoint/v3/contenttype/forms">
-  <Display>DocumentLibraryForm</Display>
-  <Edit>DocumentLibraryForm</Edit>
-  <New>DocumentLibraryForm</New>
-</FormTemplates>
-</file>
-
-<file path=customXml/item2.xml><?xml version="1.0" encoding="utf-8"?>
 <ct:contentTypeSchema xmlns:ct="http://schemas.microsoft.com/office/2006/metadata/contentType" xmlns:ma="http://schemas.microsoft.com/office/2006/metadata/properties/metaAttributes" ct:_="" ma:_="" ma:contentTypeName="Document" ma:contentTypeID="0x010100723942CCEB3A674D8F1F6472CCEFB38E" ma:contentTypeVersion="11" ma:contentTypeDescription="Create a new document." ma:contentTypeScope="" ma:versionID="e4de40d148e029d40e3aaddc8bf68a5e">
   <xsd:schema xmlns:xsd="http://www.w3.org/2001/XMLSchema" xmlns:xs="http://www.w3.org/2001/XMLSchema" xmlns:p="http://schemas.microsoft.com/office/2006/metadata/properties" xmlns:ns2="128482ec-0431-40d5-ab26-89ea2a4f3ccd" xmlns:ns3="60eb0cf4-ae2a-4762-800a-cb593b869ecb" xmlns:ns4="http://schemas.microsoft.com/sharepoint/v4" xmlns:ns5="a2e691a9-fcfc-4d85-a390-1894fe98bd9e" targetNamespace="http://schemas.microsoft.com/office/2006/metadata/properties" ma:root="true" ma:fieldsID="fce8e8bd091658f3fe51b22d57dec109" ns2:_="" ns3:_="" ns4:_="" ns5:_="">
     <xsd:import namespace="128482ec-0431-40d5-ab26-89ea2a4f3ccd"/>
@@ -5433,6 +5387,15 @@
 </ct:contentTypeSchema>
 </file>
 
+<file path=customXml/item2.xml><?xml version="1.0" encoding="utf-8"?>
+<?mso-contentType ?>
+<FormTemplates xmlns="http://schemas.microsoft.com/sharepoint/v3/contenttype/forms">
+  <Display>DocumentLibraryForm</Display>
+  <Edit>DocumentLibraryForm</Edit>
+  <New>DocumentLibraryForm</New>
+</FormTemplates>
+</file>
+
 <file path=customXml/item3.xml><?xml version="1.0" encoding="utf-8"?>
 <p:properties xmlns:p="http://schemas.microsoft.com/office/2006/metadata/properties" xmlns:xsi="http://www.w3.org/2001/XMLSchema-instance" xmlns:pc="http://schemas.microsoft.com/office/infopath/2007/PartnerControls">
   <documentManagement>
@@ -5449,14 +5412,6 @@
 </file>
 
 <file path=customXml/itemProps1.xml><?xml version="1.0" encoding="utf-8"?>
-<ds:datastoreItem xmlns:ds="http://schemas.openxmlformats.org/officeDocument/2006/customXml" ds:itemID="{AF8EC6D1-CB19-4400-AD0A-0C75CD884AEA}">
-  <ds:schemaRefs>
-    <ds:schemaRef ds:uri="http://schemas.microsoft.com/sharepoint/v3/contenttype/forms"/>
-  </ds:schemaRefs>
-</ds:datastoreItem>
-</file>
-
-<file path=customXml/itemProps2.xml><?xml version="1.0" encoding="utf-8"?>
 <ds:datastoreItem xmlns:ds="http://schemas.openxmlformats.org/officeDocument/2006/customXml" ds:itemID="{D7B8C5DE-3345-4025-A942-C5AA68E55545}">
   <ds:schemaRefs>
     <ds:schemaRef ds:uri="http://schemas.microsoft.com/office/2006/metadata/contentType"/>
@@ -5477,6 +5432,14 @@
 </ds:datastoreItem>
 </file>
 
+<file path=customXml/itemProps2.xml><?xml version="1.0" encoding="utf-8"?>
+<ds:datastoreItem xmlns:ds="http://schemas.openxmlformats.org/officeDocument/2006/customXml" ds:itemID="{AF8EC6D1-CB19-4400-AD0A-0C75CD884AEA}">
+  <ds:schemaRefs>
+    <ds:schemaRef ds:uri="http://schemas.microsoft.com/sharepoint/v3/contenttype/forms"/>
+  </ds:schemaRefs>
+</ds:datastoreItem>
+</file>
+
 <file path=customXml/itemProps3.xml><?xml version="1.0" encoding="utf-8"?>
 <ds:datastoreItem xmlns:ds="http://schemas.openxmlformats.org/officeDocument/2006/customXml" ds:itemID="{B743389A-7EE0-4951-8919-E91DD69E3687}">
   <ds:schemaRefs>

</xml_diff>